<commit_message>
anpassung an neues pinout
</commit_message>
<xml_diff>
--- a/Smarte Mülltonne/Software/Visualisierungen/Pinout Diagramm.pptx
+++ b/Smarte Mülltonne/Software/Visualisierungen/Pinout Diagramm.pptx
@@ -113,21 +113,77 @@
 </p:presentation>
 </file>
 
+<file path=ppt/revisionInfo.xml><?xml version="1.0" encoding="utf-8"?>
+<p1510:revInfo xmlns:a="http://schemas.openxmlformats.org/drawingml/2006/main" xmlns:r="http://schemas.openxmlformats.org/officeDocument/2006/relationships" xmlns:p1510="http://schemas.microsoft.com/office/powerpoint/2015/10/main">
+  <p1510:revLst>
+    <p1510:client id="{13BD13CA-E258-482D-B7BC-0539ADF64448}" v="1" dt="2026-07-04T09:17:30.921"/>
+  </p1510:revLst>
+</p1510:revInfo>
+</file>
+
 <file path=ppt/changesInfos/changesInfo1.xml><?xml version="1.0" encoding="utf-8"?>
 <pc:chgInfo xmlns:a="http://schemas.openxmlformats.org/drawingml/2006/main" xmlns:r="http://schemas.openxmlformats.org/officeDocument/2006/relationships" xmlns:ac="http://schemas.microsoft.com/office/drawing/2013/main/command" xmlns:pc="http://schemas.microsoft.com/office/powerpoint/2013/main/command">
   <pc:docChgLst>
     <pc:chgData name="Theresa Pelz" userId="ddc31a4f-cfff-4679-a101-1188f26643c0" providerId="ADAL" clId="{EB9D3BDE-398B-4CFF-AA99-85D1121C3E11}"/>
-    <pc:docChg chg="modSld">
-      <pc:chgData name="Theresa Pelz" userId="ddc31a4f-cfff-4679-a101-1188f26643c0" providerId="ADAL" clId="{EB9D3BDE-398B-4CFF-AA99-85D1121C3E11}" dt="2026-06-24T11:57:51.173" v="17" actId="207"/>
+    <pc:docChg chg="custSel modSld">
+      <pc:chgData name="Theresa Pelz" userId="ddc31a4f-cfff-4679-a101-1188f26643c0" providerId="ADAL" clId="{EB9D3BDE-398B-4CFF-AA99-85D1121C3E11}" dt="2026-07-04T09:52:08.366" v="72" actId="20577"/>
       <pc:docMkLst>
         <pc:docMk/>
       </pc:docMkLst>
-      <pc:sldChg chg="addSp modSp mod">
-        <pc:chgData name="Theresa Pelz" userId="ddc31a4f-cfff-4679-a101-1188f26643c0" providerId="ADAL" clId="{EB9D3BDE-398B-4CFF-AA99-85D1121C3E11}" dt="2026-06-24T11:57:51.173" v="17" actId="207"/>
+      <pc:sldChg chg="addSp delSp modSp mod">
+        <pc:chgData name="Theresa Pelz" userId="ddc31a4f-cfff-4679-a101-1188f26643c0" providerId="ADAL" clId="{EB9D3BDE-398B-4CFF-AA99-85D1121C3E11}" dt="2026-07-04T09:22:36.954" v="57" actId="20577"/>
         <pc:sldMkLst>
           <pc:docMk/>
           <pc:sldMk cId="713369168" sldId="257"/>
         </pc:sldMkLst>
+        <pc:spChg chg="add mod">
+          <ac:chgData name="Theresa Pelz" userId="ddc31a4f-cfff-4679-a101-1188f26643c0" providerId="ADAL" clId="{EB9D3BDE-398B-4CFF-AA99-85D1121C3E11}" dt="2026-07-04T09:17:45.077" v="31" actId="20577"/>
+          <ac:spMkLst>
+            <pc:docMk/>
+            <pc:sldMk cId="713369168" sldId="257"/>
+            <ac:spMk id="2" creationId="{01CE11D2-EBF5-D174-CC35-6DC84C03B68F}"/>
+          </ac:spMkLst>
+        </pc:spChg>
+        <pc:spChg chg="mod">
+          <ac:chgData name="Theresa Pelz" userId="ddc31a4f-cfff-4679-a101-1188f26643c0" providerId="ADAL" clId="{EB9D3BDE-398B-4CFF-AA99-85D1121C3E11}" dt="2026-07-04T09:21:53.605" v="48" actId="20577"/>
+          <ac:spMkLst>
+            <pc:docMk/>
+            <pc:sldMk cId="713369168" sldId="257"/>
+            <ac:spMk id="5" creationId="{724492E6-5338-9270-79A0-A8F6E909F435}"/>
+          </ac:spMkLst>
+        </pc:spChg>
+        <pc:spChg chg="mod">
+          <ac:chgData name="Theresa Pelz" userId="ddc31a4f-cfff-4679-a101-1188f26643c0" providerId="ADAL" clId="{EB9D3BDE-398B-4CFF-AA99-85D1121C3E11}" dt="2026-07-04T09:22:14.049" v="50" actId="20577"/>
+          <ac:spMkLst>
+            <pc:docMk/>
+            <pc:sldMk cId="713369168" sldId="257"/>
+            <ac:spMk id="6" creationId="{5AA40D78-E5DB-C1EE-1F4C-3ECE11CE9450}"/>
+          </ac:spMkLst>
+        </pc:spChg>
+        <pc:spChg chg="mod">
+          <ac:chgData name="Theresa Pelz" userId="ddc31a4f-cfff-4679-a101-1188f26643c0" providerId="ADAL" clId="{EB9D3BDE-398B-4CFF-AA99-85D1121C3E11}" dt="2026-07-04T09:22:28.782" v="52" actId="20577"/>
+          <ac:spMkLst>
+            <pc:docMk/>
+            <pc:sldMk cId="713369168" sldId="257"/>
+            <ac:spMk id="7" creationId="{20065A3A-E424-60AE-7525-7A508C07B607}"/>
+          </ac:spMkLst>
+        </pc:spChg>
+        <pc:spChg chg="mod">
+          <ac:chgData name="Theresa Pelz" userId="ddc31a4f-cfff-4679-a101-1188f26643c0" providerId="ADAL" clId="{EB9D3BDE-398B-4CFF-AA99-85D1121C3E11}" dt="2026-07-04T09:22:36.954" v="57" actId="20577"/>
+          <ac:spMkLst>
+            <pc:docMk/>
+            <pc:sldMk cId="713369168" sldId="257"/>
+            <ac:spMk id="8" creationId="{73ACC518-AABA-FABD-92B0-B5BA8B807F3D}"/>
+          </ac:spMkLst>
+        </pc:spChg>
+        <pc:spChg chg="del">
+          <ac:chgData name="Theresa Pelz" userId="ddc31a4f-cfff-4679-a101-1188f26643c0" providerId="ADAL" clId="{EB9D3BDE-398B-4CFF-AA99-85D1121C3E11}" dt="2026-07-04T09:18:37.341" v="41" actId="478"/>
+          <ac:spMkLst>
+            <pc:docMk/>
+            <pc:sldMk cId="713369168" sldId="257"/>
+            <ac:spMk id="12" creationId="{C74893B7-67FB-E91C-2BCA-7A2EC85AA879}"/>
+          </ac:spMkLst>
+        </pc:spChg>
         <pc:spChg chg="mod">
           <ac:chgData name="Theresa Pelz" userId="ddc31a4f-cfff-4679-a101-1188f26643c0" providerId="ADAL" clId="{EB9D3BDE-398B-4CFF-AA99-85D1121C3E11}" dt="2026-06-24T11:57:51.173" v="17" actId="207"/>
           <ac:spMkLst>
@@ -137,11 +193,74 @@
           </ac:spMkLst>
         </pc:spChg>
         <pc:spChg chg="add mod">
-          <ac:chgData name="Theresa Pelz" userId="ddc31a4f-cfff-4679-a101-1188f26643c0" providerId="ADAL" clId="{EB9D3BDE-398B-4CFF-AA99-85D1121C3E11}" dt="2026-06-21T10:05:23.002" v="16" actId="404"/>
+          <ac:chgData name="Theresa Pelz" userId="ddc31a4f-cfff-4679-a101-1188f26643c0" providerId="ADAL" clId="{EB9D3BDE-398B-4CFF-AA99-85D1121C3E11}" dt="2026-07-04T09:20:48.130" v="46" actId="20577"/>
           <ac:spMkLst>
             <pc:docMk/>
             <pc:sldMk cId="713369168" sldId="257"/>
             <ac:spMk id="34" creationId="{0E926472-E580-FE4E-477A-BB32F0C6E98C}"/>
+          </ac:spMkLst>
+        </pc:spChg>
+      </pc:sldChg>
+      <pc:sldChg chg="modSp mod">
+        <pc:chgData name="Theresa Pelz" userId="ddc31a4f-cfff-4679-a101-1188f26643c0" providerId="ADAL" clId="{EB9D3BDE-398B-4CFF-AA99-85D1121C3E11}" dt="2026-07-04T09:52:08.366" v="72" actId="20577"/>
+        <pc:sldMkLst>
+          <pc:docMk/>
+          <pc:sldMk cId="1401578341" sldId="258"/>
+        </pc:sldMkLst>
+        <pc:spChg chg="mod">
+          <ac:chgData name="Theresa Pelz" userId="ddc31a4f-cfff-4679-a101-1188f26643c0" providerId="ADAL" clId="{EB9D3BDE-398B-4CFF-AA99-85D1121C3E11}" dt="2026-07-04T09:52:08.366" v="72" actId="20577"/>
+          <ac:spMkLst>
+            <pc:docMk/>
+            <pc:sldMk cId="1401578341" sldId="258"/>
+            <ac:spMk id="12" creationId="{AF687845-BED5-9574-649B-B87E51F8B83B}"/>
+          </ac:spMkLst>
+        </pc:spChg>
+        <pc:spChg chg="mod">
+          <ac:chgData name="Theresa Pelz" userId="ddc31a4f-cfff-4679-a101-1188f26643c0" providerId="ADAL" clId="{EB9D3BDE-398B-4CFF-AA99-85D1121C3E11}" dt="2026-07-04T09:52:04.549" v="70" actId="20577"/>
+          <ac:spMkLst>
+            <pc:docMk/>
+            <pc:sldMk cId="1401578341" sldId="258"/>
+            <ac:spMk id="13" creationId="{26F64E60-F239-FA31-6192-2802009F68DC}"/>
+          </ac:spMkLst>
+        </pc:spChg>
+        <pc:spChg chg="mod">
+          <ac:chgData name="Theresa Pelz" userId="ddc31a4f-cfff-4679-a101-1188f26643c0" providerId="ADAL" clId="{EB9D3BDE-398B-4CFF-AA99-85D1121C3E11}" dt="2026-07-04T09:23:18.639" v="59" actId="20577"/>
+          <ac:spMkLst>
+            <pc:docMk/>
+            <pc:sldMk cId="1401578341" sldId="258"/>
+            <ac:spMk id="18" creationId="{7DD436A5-B8F7-B413-4B99-D6A66246A34B}"/>
+          </ac:spMkLst>
+        </pc:spChg>
+        <pc:spChg chg="mod">
+          <ac:chgData name="Theresa Pelz" userId="ddc31a4f-cfff-4679-a101-1188f26643c0" providerId="ADAL" clId="{EB9D3BDE-398B-4CFF-AA99-85D1121C3E11}" dt="2026-07-04T09:23:21.359" v="61" actId="20577"/>
+          <ac:spMkLst>
+            <pc:docMk/>
+            <pc:sldMk cId="1401578341" sldId="258"/>
+            <ac:spMk id="19" creationId="{BE293A67-D7CC-4366-79C1-02C82D666DAD}"/>
+          </ac:spMkLst>
+        </pc:spChg>
+        <pc:spChg chg="mod">
+          <ac:chgData name="Theresa Pelz" userId="ddc31a4f-cfff-4679-a101-1188f26643c0" providerId="ADAL" clId="{EB9D3BDE-398B-4CFF-AA99-85D1121C3E11}" dt="2026-07-04T09:23:25.313" v="63" actId="20577"/>
+          <ac:spMkLst>
+            <pc:docMk/>
+            <pc:sldMk cId="1401578341" sldId="258"/>
+            <ac:spMk id="20" creationId="{349E390A-7040-5D12-065F-737068BCFA78}"/>
+          </ac:spMkLst>
+        </pc:spChg>
+        <pc:spChg chg="mod">
+          <ac:chgData name="Theresa Pelz" userId="ddc31a4f-cfff-4679-a101-1188f26643c0" providerId="ADAL" clId="{EB9D3BDE-398B-4CFF-AA99-85D1121C3E11}" dt="2026-07-04T09:23:32.592" v="65" actId="20577"/>
+          <ac:spMkLst>
+            <pc:docMk/>
+            <pc:sldMk cId="1401578341" sldId="258"/>
+            <ac:spMk id="21" creationId="{ABE5211F-37B9-3B07-0B34-B69B7E83EBDB}"/>
+          </ac:spMkLst>
+        </pc:spChg>
+        <pc:spChg chg="mod">
+          <ac:chgData name="Theresa Pelz" userId="ddc31a4f-cfff-4679-a101-1188f26643c0" providerId="ADAL" clId="{EB9D3BDE-398B-4CFF-AA99-85D1121C3E11}" dt="2026-07-04T09:23:36.502" v="68" actId="20577"/>
+          <ac:spMkLst>
+            <pc:docMk/>
+            <pc:sldMk cId="1401578341" sldId="258"/>
+            <ac:spMk id="22" creationId="{750225D7-1FAC-FCD8-2E4A-5AA27C665A05}"/>
           </ac:spMkLst>
         </pc:spChg>
       </pc:sldChg>
@@ -297,7 +416,7 @@
           <a:p>
             <a:fld id="{60A50C7E-A74C-4D92-A00C-070A3D78B4C7}" type="datetimeFigureOut">
               <a:rPr lang="de-DE" smtClean="0"/>
-              <a:t>24.06.2026</a:t>
+              <a:t>04.07.2026</a:t>
             </a:fld>
             <a:endParaRPr lang="de-DE"/>
           </a:p>
@@ -495,7 +614,7 @@
           <a:p>
             <a:fld id="{60A50C7E-A74C-4D92-A00C-070A3D78B4C7}" type="datetimeFigureOut">
               <a:rPr lang="de-DE" smtClean="0"/>
-              <a:t>24.06.2026</a:t>
+              <a:t>04.07.2026</a:t>
             </a:fld>
             <a:endParaRPr lang="de-DE"/>
           </a:p>
@@ -703,7 +822,7 @@
           <a:p>
             <a:fld id="{60A50C7E-A74C-4D92-A00C-070A3D78B4C7}" type="datetimeFigureOut">
               <a:rPr lang="de-DE" smtClean="0"/>
-              <a:t>24.06.2026</a:t>
+              <a:t>04.07.2026</a:t>
             </a:fld>
             <a:endParaRPr lang="de-DE"/>
           </a:p>
@@ -901,7 +1020,7 @@
           <a:p>
             <a:fld id="{60A50C7E-A74C-4D92-A00C-070A3D78B4C7}" type="datetimeFigureOut">
               <a:rPr lang="de-DE" smtClean="0"/>
-              <a:t>24.06.2026</a:t>
+              <a:t>04.07.2026</a:t>
             </a:fld>
             <a:endParaRPr lang="de-DE"/>
           </a:p>
@@ -1176,7 +1295,7 @@
           <a:p>
             <a:fld id="{60A50C7E-A74C-4D92-A00C-070A3D78B4C7}" type="datetimeFigureOut">
               <a:rPr lang="de-DE" smtClean="0"/>
-              <a:t>24.06.2026</a:t>
+              <a:t>04.07.2026</a:t>
             </a:fld>
             <a:endParaRPr lang="de-DE"/>
           </a:p>
@@ -1441,7 +1560,7 @@
           <a:p>
             <a:fld id="{60A50C7E-A74C-4D92-A00C-070A3D78B4C7}" type="datetimeFigureOut">
               <a:rPr lang="de-DE" smtClean="0"/>
-              <a:t>24.06.2026</a:t>
+              <a:t>04.07.2026</a:t>
             </a:fld>
             <a:endParaRPr lang="de-DE"/>
           </a:p>
@@ -1853,7 +1972,7 @@
           <a:p>
             <a:fld id="{60A50C7E-A74C-4D92-A00C-070A3D78B4C7}" type="datetimeFigureOut">
               <a:rPr lang="de-DE" smtClean="0"/>
-              <a:t>24.06.2026</a:t>
+              <a:t>04.07.2026</a:t>
             </a:fld>
             <a:endParaRPr lang="de-DE"/>
           </a:p>
@@ -1994,7 +2113,7 @@
           <a:p>
             <a:fld id="{60A50C7E-A74C-4D92-A00C-070A3D78B4C7}" type="datetimeFigureOut">
               <a:rPr lang="de-DE" smtClean="0"/>
-              <a:t>24.06.2026</a:t>
+              <a:t>04.07.2026</a:t>
             </a:fld>
             <a:endParaRPr lang="de-DE"/>
           </a:p>
@@ -2107,7 +2226,7 @@
           <a:p>
             <a:fld id="{60A50C7E-A74C-4D92-A00C-070A3D78B4C7}" type="datetimeFigureOut">
               <a:rPr lang="de-DE" smtClean="0"/>
-              <a:t>24.06.2026</a:t>
+              <a:t>04.07.2026</a:t>
             </a:fld>
             <a:endParaRPr lang="de-DE"/>
           </a:p>
@@ -2418,7 +2537,7 @@
           <a:p>
             <a:fld id="{60A50C7E-A74C-4D92-A00C-070A3D78B4C7}" type="datetimeFigureOut">
               <a:rPr lang="de-DE" smtClean="0"/>
-              <a:t>24.06.2026</a:t>
+              <a:t>04.07.2026</a:t>
             </a:fld>
             <a:endParaRPr lang="de-DE"/>
           </a:p>
@@ -2706,7 +2825,7 @@
           <a:p>
             <a:fld id="{60A50C7E-A74C-4D92-A00C-070A3D78B4C7}" type="datetimeFigureOut">
               <a:rPr lang="de-DE" smtClean="0"/>
-              <a:t>24.06.2026</a:t>
+              <a:t>04.07.2026</a:t>
             </a:fld>
             <a:endParaRPr lang="de-DE"/>
           </a:p>
@@ -2947,7 +3066,7 @@
           <a:p>
             <a:fld id="{60A50C7E-A74C-4D92-A00C-070A3D78B4C7}" type="datetimeFigureOut">
               <a:rPr lang="de-DE" smtClean="0"/>
-              <a:t>24.06.2026</a:t>
+              <a:t>04.07.2026</a:t>
             </a:fld>
             <a:endParaRPr lang="de-DE"/>
           </a:p>
@@ -3448,7 +3567,7 @@
             <a:pPr algn="ctr"/>
             <a:r>
               <a:rPr lang="de-DE" sz="800" dirty="0"/>
-              <a:t>MUX S0</a:t>
+              <a:t>MUX S1</a:t>
             </a:r>
             <a:endParaRPr lang="de-DE" dirty="0"/>
           </a:p>
@@ -3502,7 +3621,7 @@
             <a:pPr algn="ctr"/>
             <a:r>
               <a:rPr lang="de-DE" sz="800" dirty="0"/>
-              <a:t>MUX S1</a:t>
+              <a:t>MUX S2</a:t>
             </a:r>
             <a:endParaRPr lang="de-DE" dirty="0"/>
           </a:p>
@@ -3556,7 +3675,7 @@
             <a:pPr algn="ctr"/>
             <a:r>
               <a:rPr lang="de-DE" sz="800" dirty="0"/>
-              <a:t>MUX S2</a:t>
+              <a:t>MUX S3</a:t>
             </a:r>
             <a:endParaRPr lang="de-DE" dirty="0"/>
           </a:p>
@@ -3610,7 +3729,7 @@
             <a:pPr algn="ctr"/>
             <a:r>
               <a:rPr lang="de-DE" sz="800" dirty="0"/>
-              <a:t>MUX S3</a:t>
+              <a:t>MUX SIG</a:t>
             </a:r>
             <a:endParaRPr lang="de-DE" dirty="0"/>
           </a:p>
@@ -3671,10 +3790,10 @@
       </p:sp>
       <p:sp>
         <p:nvSpPr>
-          <p:cNvPr id="12" name="Rechteck 11">
-            <a:extLst>
-              <a:ext uri="{FF2B5EF4-FFF2-40B4-BE49-F238E27FC236}">
-                <a16:creationId xmlns:a16="http://schemas.microsoft.com/office/drawing/2014/main" id="{C74893B7-67FB-E91C-2BCA-7A2EC85AA879}"/>
+          <p:cNvPr id="13" name="Rechteck 12">
+            <a:extLst>
+              <a:ext uri="{FF2B5EF4-FFF2-40B4-BE49-F238E27FC236}">
+                <a16:creationId xmlns:a16="http://schemas.microsoft.com/office/drawing/2014/main" id="{0EC9EEE4-C33C-898B-0988-78C365592BFD}"/>
               </a:ext>
             </a:extLst>
           </p:cNvPr>
@@ -3683,7 +3802,7 @@
         </p:nvSpPr>
         <p:spPr>
           <a:xfrm>
-            <a:off x="5584137" y="2976372"/>
+            <a:off x="5584137" y="3412185"/>
             <a:ext cx="792000" cy="155448"/>
           </a:xfrm>
           <a:prstGeom prst="rect">
@@ -3716,19 +3835,18 @@
           <a:p>
             <a:pPr algn="ctr"/>
             <a:r>
-              <a:rPr lang="de-DE" sz="800" dirty="0"/>
-              <a:t>MUX SIG</a:t>
-            </a:r>
-            <a:endParaRPr lang="de-DE" dirty="0"/>
-          </a:p>
-        </p:txBody>
-      </p:sp>
-      <p:sp>
-        <p:nvSpPr>
-          <p:cNvPr id="13" name="Rechteck 12">
-            <a:extLst>
-              <a:ext uri="{FF2B5EF4-FFF2-40B4-BE49-F238E27FC236}">
-                <a16:creationId xmlns:a16="http://schemas.microsoft.com/office/drawing/2014/main" id="{0EC9EEE4-C33C-898B-0988-78C365592BFD}"/>
+              <a:rPr lang="de-DE" sz="600" dirty="0"/>
+              <a:t>Spannungsteiler</a:t>
+            </a:r>
+          </a:p>
+        </p:txBody>
+      </p:sp>
+      <p:sp>
+        <p:nvSpPr>
+          <p:cNvPr id="14" name="Rechteck 13">
+            <a:extLst>
+              <a:ext uri="{FF2B5EF4-FFF2-40B4-BE49-F238E27FC236}">
+                <a16:creationId xmlns:a16="http://schemas.microsoft.com/office/drawing/2014/main" id="{CEF25083-514B-B993-3F6A-9CAF39F5B621}"/>
               </a:ext>
             </a:extLst>
           </p:cNvPr>
@@ -3737,7 +3855,7 @@
         </p:nvSpPr>
         <p:spPr>
           <a:xfrm>
-            <a:off x="5584137" y="3412185"/>
+            <a:off x="4626864" y="3844899"/>
             <a:ext cx="792000" cy="155448"/>
           </a:xfrm>
           <a:prstGeom prst="rect">
@@ -3770,18 +3888,19 @@
           <a:p>
             <a:pPr algn="ctr"/>
             <a:r>
-              <a:rPr lang="de-DE" sz="600" dirty="0"/>
-              <a:t>Spannungsteiler</a:t>
-            </a:r>
-          </a:p>
-        </p:txBody>
-      </p:sp>
-      <p:sp>
-        <p:nvSpPr>
-          <p:cNvPr id="14" name="Rechteck 13">
-            <a:extLst>
-              <a:ext uri="{FF2B5EF4-FFF2-40B4-BE49-F238E27FC236}">
-                <a16:creationId xmlns:a16="http://schemas.microsoft.com/office/drawing/2014/main" id="{CEF25083-514B-B993-3F6A-9CAF39F5B621}"/>
+              <a:rPr lang="de-DE" sz="800" dirty="0"/>
+              <a:t>Motor R STEP</a:t>
+            </a:r>
+            <a:endParaRPr lang="de-DE" dirty="0"/>
+          </a:p>
+        </p:txBody>
+      </p:sp>
+      <p:sp>
+        <p:nvSpPr>
+          <p:cNvPr id="15" name="Rechteck 14">
+            <a:extLst>
+              <a:ext uri="{FF2B5EF4-FFF2-40B4-BE49-F238E27FC236}">
+                <a16:creationId xmlns:a16="http://schemas.microsoft.com/office/drawing/2014/main" id="{829469EF-31C7-C40E-5348-AEDEF131A91D}"/>
               </a:ext>
             </a:extLst>
           </p:cNvPr>
@@ -3790,7 +3909,7 @@
         </p:nvSpPr>
         <p:spPr>
           <a:xfrm>
-            <a:off x="4626864" y="3844899"/>
+            <a:off x="4626864" y="4055365"/>
             <a:ext cx="792000" cy="155448"/>
           </a:xfrm>
           <a:prstGeom prst="rect">
@@ -3823,19 +3942,18 @@
           <a:p>
             <a:pPr algn="ctr"/>
             <a:r>
-              <a:rPr lang="de-DE" sz="800" dirty="0"/>
-              <a:t>Motor R STEP</a:t>
-            </a:r>
-            <a:endParaRPr lang="de-DE" dirty="0"/>
-          </a:p>
-        </p:txBody>
-      </p:sp>
-      <p:sp>
-        <p:nvSpPr>
-          <p:cNvPr id="15" name="Rechteck 14">
-            <a:extLst>
-              <a:ext uri="{FF2B5EF4-FFF2-40B4-BE49-F238E27FC236}">
-                <a16:creationId xmlns:a16="http://schemas.microsoft.com/office/drawing/2014/main" id="{829469EF-31C7-C40E-5348-AEDEF131A91D}"/>
+              <a:rPr lang="de-DE" sz="650" dirty="0"/>
+              <a:t>Motor R ENABLE</a:t>
+            </a:r>
+          </a:p>
+        </p:txBody>
+      </p:sp>
+      <p:sp>
+        <p:nvSpPr>
+          <p:cNvPr id="17" name="Rechteck 16">
+            <a:extLst>
+              <a:ext uri="{FF2B5EF4-FFF2-40B4-BE49-F238E27FC236}">
+                <a16:creationId xmlns:a16="http://schemas.microsoft.com/office/drawing/2014/main" id="{55E9DD42-6630-9E52-D05E-B5CBE8D48815}"/>
               </a:ext>
             </a:extLst>
           </p:cNvPr>
@@ -3844,7 +3962,7 @@
         </p:nvSpPr>
         <p:spPr>
           <a:xfrm>
-            <a:off x="4626864" y="4055365"/>
+            <a:off x="4626864" y="4457701"/>
             <a:ext cx="792000" cy="155448"/>
           </a:xfrm>
           <a:prstGeom prst="rect">
@@ -3877,18 +3995,19 @@
           <a:p>
             <a:pPr algn="ctr"/>
             <a:r>
-              <a:rPr lang="de-DE" sz="650" dirty="0"/>
-              <a:t>Motor R ENABLE</a:t>
-            </a:r>
-          </a:p>
-        </p:txBody>
-      </p:sp>
-      <p:sp>
-        <p:nvSpPr>
-          <p:cNvPr id="17" name="Rechteck 16">
-            <a:extLst>
-              <a:ext uri="{FF2B5EF4-FFF2-40B4-BE49-F238E27FC236}">
-                <a16:creationId xmlns:a16="http://schemas.microsoft.com/office/drawing/2014/main" id="{55E9DD42-6630-9E52-D05E-B5CBE8D48815}"/>
+              <a:rPr lang="de-DE" sz="800" dirty="0"/>
+              <a:t>Motor L DIR</a:t>
+            </a:r>
+            <a:endParaRPr lang="de-DE" dirty="0"/>
+          </a:p>
+        </p:txBody>
+      </p:sp>
+      <p:sp>
+        <p:nvSpPr>
+          <p:cNvPr id="18" name="Rechteck 17">
+            <a:extLst>
+              <a:ext uri="{FF2B5EF4-FFF2-40B4-BE49-F238E27FC236}">
+                <a16:creationId xmlns:a16="http://schemas.microsoft.com/office/drawing/2014/main" id="{F81F056D-2CBD-F44C-080E-0C170B2BD404}"/>
               </a:ext>
             </a:extLst>
           </p:cNvPr>
@@ -3897,7 +4016,7 @@
         </p:nvSpPr>
         <p:spPr>
           <a:xfrm>
-            <a:off x="4626864" y="4457701"/>
+            <a:off x="4626864" y="4658869"/>
             <a:ext cx="792000" cy="155448"/>
           </a:xfrm>
           <a:prstGeom prst="rect">
@@ -3931,7 +4050,7 @@
             <a:pPr algn="ctr"/>
             <a:r>
               <a:rPr lang="de-DE" sz="800" dirty="0"/>
-              <a:t>Motor L DIR</a:t>
+              <a:t>Motor L STEP</a:t>
             </a:r>
             <a:endParaRPr lang="de-DE" dirty="0"/>
           </a:p>
@@ -3939,10 +4058,10 @@
       </p:sp>
       <p:sp>
         <p:nvSpPr>
-          <p:cNvPr id="18" name="Rechteck 17">
-            <a:extLst>
-              <a:ext uri="{FF2B5EF4-FFF2-40B4-BE49-F238E27FC236}">
-                <a16:creationId xmlns:a16="http://schemas.microsoft.com/office/drawing/2014/main" id="{F81F056D-2CBD-F44C-080E-0C170B2BD404}"/>
+          <p:cNvPr id="19" name="Rechteck 18">
+            <a:extLst>
+              <a:ext uri="{FF2B5EF4-FFF2-40B4-BE49-F238E27FC236}">
+                <a16:creationId xmlns:a16="http://schemas.microsoft.com/office/drawing/2014/main" id="{946141D3-D648-355B-38D0-6CF58C2E87F1}"/>
               </a:ext>
             </a:extLst>
           </p:cNvPr>
@@ -3951,7 +4070,7 @@
         </p:nvSpPr>
         <p:spPr>
           <a:xfrm>
-            <a:off x="4626864" y="4658869"/>
+            <a:off x="4626864" y="4860037"/>
             <a:ext cx="792000" cy="155448"/>
           </a:xfrm>
           <a:prstGeom prst="rect">
@@ -3984,19 +4103,18 @@
           <a:p>
             <a:pPr algn="ctr"/>
             <a:r>
-              <a:rPr lang="de-DE" sz="800" dirty="0"/>
-              <a:t>Motor L STEP</a:t>
-            </a:r>
-            <a:endParaRPr lang="de-DE" dirty="0"/>
-          </a:p>
-        </p:txBody>
-      </p:sp>
-      <p:sp>
-        <p:nvSpPr>
-          <p:cNvPr id="19" name="Rechteck 18">
-            <a:extLst>
-              <a:ext uri="{FF2B5EF4-FFF2-40B4-BE49-F238E27FC236}">
-                <a16:creationId xmlns:a16="http://schemas.microsoft.com/office/drawing/2014/main" id="{946141D3-D648-355B-38D0-6CF58C2E87F1}"/>
+              <a:rPr lang="de-DE" sz="650" dirty="0"/>
+              <a:t>Motor L ENABLE</a:t>
+            </a:r>
+          </a:p>
+        </p:txBody>
+      </p:sp>
+      <p:sp>
+        <p:nvSpPr>
+          <p:cNvPr id="20" name="Rechteck 19">
+            <a:extLst>
+              <a:ext uri="{FF2B5EF4-FFF2-40B4-BE49-F238E27FC236}">
+                <a16:creationId xmlns:a16="http://schemas.microsoft.com/office/drawing/2014/main" id="{8DDBD53D-03A7-2B32-A4F5-088D1B12275A}"/>
               </a:ext>
             </a:extLst>
           </p:cNvPr>
@@ -4005,7 +4123,7 @@
         </p:nvSpPr>
         <p:spPr>
           <a:xfrm>
-            <a:off x="4626864" y="4860037"/>
+            <a:off x="4626864" y="5080029"/>
             <a:ext cx="792000" cy="155448"/>
           </a:xfrm>
           <a:prstGeom prst="rect">
@@ -4038,18 +4156,19 @@
           <a:p>
             <a:pPr algn="ctr"/>
             <a:r>
-              <a:rPr lang="de-DE" sz="650" dirty="0"/>
-              <a:t>Motor L ENABLE</a:t>
-            </a:r>
-          </a:p>
-        </p:txBody>
-      </p:sp>
-      <p:sp>
-        <p:nvSpPr>
-          <p:cNvPr id="20" name="Rechteck 19">
-            <a:extLst>
-              <a:ext uri="{FF2B5EF4-FFF2-40B4-BE49-F238E27FC236}">
-                <a16:creationId xmlns:a16="http://schemas.microsoft.com/office/drawing/2014/main" id="{8DDBD53D-03A7-2B32-A4F5-088D1B12275A}"/>
+              <a:rPr lang="de-DE" sz="800" dirty="0"/>
+              <a:t>Motor R DIR</a:t>
+            </a:r>
+            <a:endParaRPr lang="de-DE" dirty="0"/>
+          </a:p>
+        </p:txBody>
+      </p:sp>
+      <p:sp>
+        <p:nvSpPr>
+          <p:cNvPr id="21" name="Rechteck 20">
+            <a:extLst>
+              <a:ext uri="{FF2B5EF4-FFF2-40B4-BE49-F238E27FC236}">
+                <a16:creationId xmlns:a16="http://schemas.microsoft.com/office/drawing/2014/main" id="{D5593BF1-D4AF-67FE-BDED-0677FF5EAD83}"/>
               </a:ext>
             </a:extLst>
           </p:cNvPr>
@@ -4058,7 +4177,61 @@
         </p:nvSpPr>
         <p:spPr>
           <a:xfrm>
-            <a:off x="4626864" y="5080029"/>
+            <a:off x="5584137" y="1965960"/>
+            <a:ext cx="792000" cy="155448"/>
+          </a:xfrm>
+          <a:prstGeom prst="rect">
+            <a:avLst/>
+          </a:prstGeom>
+          <a:solidFill>
+            <a:srgbClr val="FF0000"/>
+          </a:solidFill>
+          <a:ln>
+            <a:noFill/>
+          </a:ln>
+        </p:spPr>
+        <p:style>
+          <a:lnRef idx="0">
+            <a:scrgbClr r="0" g="0" b="0"/>
+          </a:lnRef>
+          <a:fillRef idx="0">
+            <a:scrgbClr r="0" g="0" b="0"/>
+          </a:fillRef>
+          <a:effectRef idx="0">
+            <a:scrgbClr r="0" g="0" b="0"/>
+          </a:effectRef>
+          <a:fontRef idx="minor">
+            <a:schemeClr val="lt1"/>
+          </a:fontRef>
+        </p:style>
+        <p:txBody>
+          <a:bodyPr rtlCol="0" anchor="ctr"/>
+          <a:lstStyle/>
+          <a:p>
+            <a:pPr algn="ctr"/>
+            <a:r>
+              <a:rPr lang="de-DE" sz="800" dirty="0"/>
+              <a:t>Konverter </a:t>
+            </a:r>
+            <a:endParaRPr lang="de-DE" dirty="0"/>
+          </a:p>
+        </p:txBody>
+      </p:sp>
+      <p:sp>
+        <p:nvSpPr>
+          <p:cNvPr id="24" name="Rechteck 23">
+            <a:extLst>
+              <a:ext uri="{FF2B5EF4-FFF2-40B4-BE49-F238E27FC236}">
+                <a16:creationId xmlns:a16="http://schemas.microsoft.com/office/drawing/2014/main" id="{2C3EB243-86D5-FD8E-7A05-11DA6614DF64}"/>
+              </a:ext>
+            </a:extLst>
+          </p:cNvPr>
+          <p:cNvSpPr/>
+          <p:nvPr/>
+        </p:nvSpPr>
+        <p:spPr>
+          <a:xfrm>
+            <a:off x="5584137" y="5080029"/>
             <a:ext cx="792000" cy="155448"/>
           </a:xfrm>
           <a:prstGeom prst="rect">
@@ -4092,7 +4265,7 @@
             <a:pPr algn="ctr"/>
             <a:r>
               <a:rPr lang="de-DE" sz="800" dirty="0"/>
-              <a:t>Motor R DIR</a:t>
+              <a:t>Touch SCK</a:t>
             </a:r>
             <a:endParaRPr lang="de-DE" dirty="0"/>
           </a:p>
@@ -4100,10 +4273,10 @@
       </p:sp>
       <p:sp>
         <p:nvSpPr>
-          <p:cNvPr id="21" name="Rechteck 20">
-            <a:extLst>
-              <a:ext uri="{FF2B5EF4-FFF2-40B4-BE49-F238E27FC236}">
-                <a16:creationId xmlns:a16="http://schemas.microsoft.com/office/drawing/2014/main" id="{D5593BF1-D4AF-67FE-BDED-0677FF5EAD83}"/>
+          <p:cNvPr id="25" name="Rechteck 24">
+            <a:extLst>
+              <a:ext uri="{FF2B5EF4-FFF2-40B4-BE49-F238E27FC236}">
+                <a16:creationId xmlns:a16="http://schemas.microsoft.com/office/drawing/2014/main" id="{E1929955-BC87-EAE5-C210-4322B4B89540}"/>
               </a:ext>
             </a:extLst>
           </p:cNvPr>
@@ -4112,61 +4285,7 @@
         </p:nvSpPr>
         <p:spPr>
           <a:xfrm>
-            <a:off x="5584137" y="1965960"/>
-            <a:ext cx="792000" cy="155448"/>
-          </a:xfrm>
-          <a:prstGeom prst="rect">
-            <a:avLst/>
-          </a:prstGeom>
-          <a:solidFill>
-            <a:srgbClr val="FF0000"/>
-          </a:solidFill>
-          <a:ln>
-            <a:noFill/>
-          </a:ln>
-        </p:spPr>
-        <p:style>
-          <a:lnRef idx="0">
-            <a:scrgbClr r="0" g="0" b="0"/>
-          </a:lnRef>
-          <a:fillRef idx="0">
-            <a:scrgbClr r="0" g="0" b="0"/>
-          </a:fillRef>
-          <a:effectRef idx="0">
-            <a:scrgbClr r="0" g="0" b="0"/>
-          </a:effectRef>
-          <a:fontRef idx="minor">
-            <a:schemeClr val="lt1"/>
-          </a:fontRef>
-        </p:style>
-        <p:txBody>
-          <a:bodyPr rtlCol="0" anchor="ctr"/>
-          <a:lstStyle/>
-          <a:p>
-            <a:pPr algn="ctr"/>
-            <a:r>
-              <a:rPr lang="de-DE" sz="800" dirty="0"/>
-              <a:t>Konverter </a:t>
-            </a:r>
-            <a:endParaRPr lang="de-DE" dirty="0"/>
-          </a:p>
-        </p:txBody>
-      </p:sp>
-      <p:sp>
-        <p:nvSpPr>
-          <p:cNvPr id="24" name="Rechteck 23">
-            <a:extLst>
-              <a:ext uri="{FF2B5EF4-FFF2-40B4-BE49-F238E27FC236}">
-                <a16:creationId xmlns:a16="http://schemas.microsoft.com/office/drawing/2014/main" id="{2C3EB243-86D5-FD8E-7A05-11DA6614DF64}"/>
-              </a:ext>
-            </a:extLst>
-          </p:cNvPr>
-          <p:cNvSpPr/>
-          <p:nvPr/>
-        </p:nvSpPr>
-        <p:spPr>
-          <a:xfrm>
-            <a:off x="5584137" y="5080029"/>
+            <a:off x="5584137" y="4860037"/>
             <a:ext cx="792000" cy="155448"/>
           </a:xfrm>
           <a:prstGeom prst="rect">
@@ -4200,7 +4319,7 @@
             <a:pPr algn="ctr"/>
             <a:r>
               <a:rPr lang="de-DE" sz="800" dirty="0"/>
-              <a:t>Touch SCK</a:t>
+              <a:t>Touch MOSI</a:t>
             </a:r>
             <a:endParaRPr lang="de-DE" dirty="0"/>
           </a:p>
@@ -4208,10 +4327,10 @@
       </p:sp>
       <p:sp>
         <p:nvSpPr>
-          <p:cNvPr id="25" name="Rechteck 24">
-            <a:extLst>
-              <a:ext uri="{FF2B5EF4-FFF2-40B4-BE49-F238E27FC236}">
-                <a16:creationId xmlns:a16="http://schemas.microsoft.com/office/drawing/2014/main" id="{E1929955-BC87-EAE5-C210-4322B4B89540}"/>
+          <p:cNvPr id="26" name="Rechteck 25">
+            <a:extLst>
+              <a:ext uri="{FF2B5EF4-FFF2-40B4-BE49-F238E27FC236}">
+                <a16:creationId xmlns:a16="http://schemas.microsoft.com/office/drawing/2014/main" id="{B1873659-D2B8-344C-D197-5FF0568DD824}"/>
               </a:ext>
             </a:extLst>
           </p:cNvPr>
@@ -4220,7 +4339,7 @@
         </p:nvSpPr>
         <p:spPr>
           <a:xfrm>
-            <a:off x="5584137" y="4860037"/>
+            <a:off x="5584137" y="4658869"/>
             <a:ext cx="792000" cy="155448"/>
           </a:xfrm>
           <a:prstGeom prst="rect">
@@ -4254,7 +4373,7 @@
             <a:pPr algn="ctr"/>
             <a:r>
               <a:rPr lang="de-DE" sz="800" dirty="0"/>
-              <a:t>Touch MOSI</a:t>
+              <a:t>Display DC</a:t>
             </a:r>
             <a:endParaRPr lang="de-DE" dirty="0"/>
           </a:p>
@@ -4262,10 +4381,10 @@
       </p:sp>
       <p:sp>
         <p:nvSpPr>
-          <p:cNvPr id="26" name="Rechteck 25">
-            <a:extLst>
-              <a:ext uri="{FF2B5EF4-FFF2-40B4-BE49-F238E27FC236}">
-                <a16:creationId xmlns:a16="http://schemas.microsoft.com/office/drawing/2014/main" id="{B1873659-D2B8-344C-D197-5FF0568DD824}"/>
+          <p:cNvPr id="27" name="Rechteck 26">
+            <a:extLst>
+              <a:ext uri="{FF2B5EF4-FFF2-40B4-BE49-F238E27FC236}">
+                <a16:creationId xmlns:a16="http://schemas.microsoft.com/office/drawing/2014/main" id="{C86FC1DF-6E0D-7697-8A08-9344937EC077}"/>
               </a:ext>
             </a:extLst>
           </p:cNvPr>
@@ -4274,7 +4393,7 @@
         </p:nvSpPr>
         <p:spPr>
           <a:xfrm>
-            <a:off x="5584137" y="4658869"/>
+            <a:off x="5584137" y="4457701"/>
             <a:ext cx="792000" cy="155448"/>
           </a:xfrm>
           <a:prstGeom prst="rect">
@@ -4308,7 +4427,7 @@
             <a:pPr algn="ctr"/>
             <a:r>
               <a:rPr lang="de-DE" sz="800" dirty="0"/>
-              <a:t>Display DC</a:t>
+              <a:t>Display RST</a:t>
             </a:r>
             <a:endParaRPr lang="de-DE" dirty="0"/>
           </a:p>
@@ -4316,10 +4435,10 @@
       </p:sp>
       <p:sp>
         <p:nvSpPr>
-          <p:cNvPr id="27" name="Rechteck 26">
-            <a:extLst>
-              <a:ext uri="{FF2B5EF4-FFF2-40B4-BE49-F238E27FC236}">
-                <a16:creationId xmlns:a16="http://schemas.microsoft.com/office/drawing/2014/main" id="{C86FC1DF-6E0D-7697-8A08-9344937EC077}"/>
+          <p:cNvPr id="28" name="Rechteck 27">
+            <a:extLst>
+              <a:ext uri="{FF2B5EF4-FFF2-40B4-BE49-F238E27FC236}">
+                <a16:creationId xmlns:a16="http://schemas.microsoft.com/office/drawing/2014/main" id="{7887BAD6-DEEB-0C2D-7125-1DC50D80801D}"/>
               </a:ext>
             </a:extLst>
           </p:cNvPr>
@@ -4328,7 +4447,7 @@
         </p:nvSpPr>
         <p:spPr>
           <a:xfrm>
-            <a:off x="5584137" y="4457701"/>
+            <a:off x="5584137" y="4053332"/>
             <a:ext cx="792000" cy="155448"/>
           </a:xfrm>
           <a:prstGeom prst="rect">
@@ -4362,7 +4481,7 @@
             <a:pPr algn="ctr"/>
             <a:r>
               <a:rPr lang="de-DE" sz="800" dirty="0"/>
-              <a:t>Display RST</a:t>
+              <a:t>Touch CS</a:t>
             </a:r>
             <a:endParaRPr lang="de-DE" dirty="0"/>
           </a:p>
@@ -4370,10 +4489,10 @@
       </p:sp>
       <p:sp>
         <p:nvSpPr>
-          <p:cNvPr id="28" name="Rechteck 27">
-            <a:extLst>
-              <a:ext uri="{FF2B5EF4-FFF2-40B4-BE49-F238E27FC236}">
-                <a16:creationId xmlns:a16="http://schemas.microsoft.com/office/drawing/2014/main" id="{7887BAD6-DEEB-0C2D-7125-1DC50D80801D}"/>
+          <p:cNvPr id="29" name="Rechteck 28">
+            <a:extLst>
+              <a:ext uri="{FF2B5EF4-FFF2-40B4-BE49-F238E27FC236}">
+                <a16:creationId xmlns:a16="http://schemas.microsoft.com/office/drawing/2014/main" id="{47E3711A-5F43-6D43-8A6C-57047176A656}"/>
               </a:ext>
             </a:extLst>
           </p:cNvPr>
@@ -4382,7 +4501,7 @@
         </p:nvSpPr>
         <p:spPr>
           <a:xfrm>
-            <a:off x="5584137" y="4053332"/>
+            <a:off x="5584137" y="3613556"/>
             <a:ext cx="792000" cy="155448"/>
           </a:xfrm>
           <a:prstGeom prst="rect">
@@ -4416,7 +4535,7 @@
             <a:pPr algn="ctr"/>
             <a:r>
               <a:rPr lang="de-DE" sz="800" dirty="0"/>
-              <a:t>Touch CS</a:t>
+              <a:t>Touch IRQ</a:t>
             </a:r>
             <a:endParaRPr lang="de-DE" dirty="0"/>
           </a:p>
@@ -4424,10 +4543,10 @@
       </p:sp>
       <p:sp>
         <p:nvSpPr>
-          <p:cNvPr id="29" name="Rechteck 28">
-            <a:extLst>
-              <a:ext uri="{FF2B5EF4-FFF2-40B4-BE49-F238E27FC236}">
-                <a16:creationId xmlns:a16="http://schemas.microsoft.com/office/drawing/2014/main" id="{47E3711A-5F43-6D43-8A6C-57047176A656}"/>
+          <p:cNvPr id="30" name="Rechteck 29">
+            <a:extLst>
+              <a:ext uri="{FF2B5EF4-FFF2-40B4-BE49-F238E27FC236}">
+                <a16:creationId xmlns:a16="http://schemas.microsoft.com/office/drawing/2014/main" id="{EC7594DE-1E11-A10A-ADA7-03E3DD812CE3}"/>
               </a:ext>
             </a:extLst>
           </p:cNvPr>
@@ -4436,7 +4555,7 @@
         </p:nvSpPr>
         <p:spPr>
           <a:xfrm>
-            <a:off x="5584137" y="3613556"/>
+            <a:off x="5584137" y="5719507"/>
             <a:ext cx="792000" cy="155448"/>
           </a:xfrm>
           <a:prstGeom prst="rect">
@@ -4470,7 +4589,7 @@
             <a:pPr algn="ctr"/>
             <a:r>
               <a:rPr lang="de-DE" sz="800" dirty="0"/>
-              <a:t>Touch IRQ</a:t>
+              <a:t>Touch MISO</a:t>
             </a:r>
             <a:endParaRPr lang="de-DE" dirty="0"/>
           </a:p>
@@ -4478,10 +4597,10 @@
       </p:sp>
       <p:sp>
         <p:nvSpPr>
-          <p:cNvPr id="30" name="Rechteck 29">
-            <a:extLst>
-              <a:ext uri="{FF2B5EF4-FFF2-40B4-BE49-F238E27FC236}">
-                <a16:creationId xmlns:a16="http://schemas.microsoft.com/office/drawing/2014/main" id="{EC7594DE-1E11-A10A-ADA7-03E3DD812CE3}"/>
+          <p:cNvPr id="31" name="Rechteck 30">
+            <a:extLst>
+              <a:ext uri="{FF2B5EF4-FFF2-40B4-BE49-F238E27FC236}">
+                <a16:creationId xmlns:a16="http://schemas.microsoft.com/office/drawing/2014/main" id="{F44614DB-66DF-3D81-76B5-D0F87E4B7DD8}"/>
               </a:ext>
             </a:extLst>
           </p:cNvPr>
@@ -4490,7 +4609,7 @@
         </p:nvSpPr>
         <p:spPr>
           <a:xfrm>
-            <a:off x="5584137" y="5719507"/>
+            <a:off x="5584137" y="5499515"/>
             <a:ext cx="792000" cy="155448"/>
           </a:xfrm>
           <a:prstGeom prst="rect">
@@ -4524,7 +4643,7 @@
             <a:pPr algn="ctr"/>
             <a:r>
               <a:rPr lang="de-DE" sz="800" dirty="0"/>
-              <a:t>Touch MISO</a:t>
+              <a:t>Display CS</a:t>
             </a:r>
             <a:endParaRPr lang="de-DE" dirty="0"/>
           </a:p>
@@ -4532,10 +4651,10 @@
       </p:sp>
       <p:sp>
         <p:nvSpPr>
-          <p:cNvPr id="31" name="Rechteck 30">
-            <a:extLst>
-              <a:ext uri="{FF2B5EF4-FFF2-40B4-BE49-F238E27FC236}">
-                <a16:creationId xmlns:a16="http://schemas.microsoft.com/office/drawing/2014/main" id="{F44614DB-66DF-3D81-76B5-D0F87E4B7DD8}"/>
+          <p:cNvPr id="33" name="Rechteck 32">
+            <a:extLst>
+              <a:ext uri="{FF2B5EF4-FFF2-40B4-BE49-F238E27FC236}">
+                <a16:creationId xmlns:a16="http://schemas.microsoft.com/office/drawing/2014/main" id="{F0C3CB0F-7B89-7A8A-F502-4706B835F3A2}"/>
               </a:ext>
             </a:extLst>
           </p:cNvPr>
@@ -4544,7 +4663,7 @@
         </p:nvSpPr>
         <p:spPr>
           <a:xfrm>
-            <a:off x="5584137" y="5499515"/>
+            <a:off x="4626864" y="1745568"/>
             <a:ext cx="792000" cy="155448"/>
           </a:xfrm>
           <a:prstGeom prst="rect">
@@ -4578,7 +4697,7 @@
             <a:pPr algn="ctr"/>
             <a:r>
               <a:rPr lang="de-DE" sz="800" dirty="0"/>
-              <a:t>Display CS</a:t>
+              <a:t>Buzzer</a:t>
             </a:r>
             <a:endParaRPr lang="de-DE" dirty="0"/>
           </a:p>
@@ -4586,10 +4705,10 @@
       </p:sp>
       <p:sp>
         <p:nvSpPr>
-          <p:cNvPr id="33" name="Rechteck 32">
-            <a:extLst>
-              <a:ext uri="{FF2B5EF4-FFF2-40B4-BE49-F238E27FC236}">
-                <a16:creationId xmlns:a16="http://schemas.microsoft.com/office/drawing/2014/main" id="{F0C3CB0F-7B89-7A8A-F502-4706B835F3A2}"/>
+          <p:cNvPr id="34" name="Rechteck 33">
+            <a:extLst>
+              <a:ext uri="{FF2B5EF4-FFF2-40B4-BE49-F238E27FC236}">
+                <a16:creationId xmlns:a16="http://schemas.microsoft.com/office/drawing/2014/main" id="{0E926472-E580-FE4E-477A-BB32F0C6E98C}"/>
               </a:ext>
             </a:extLst>
           </p:cNvPr>
@@ -4598,7 +4717,7 @@
         </p:nvSpPr>
         <p:spPr>
           <a:xfrm>
-            <a:off x="4626864" y="1745568"/>
+            <a:off x="4626864" y="1963474"/>
             <a:ext cx="792000" cy="155448"/>
           </a:xfrm>
           <a:prstGeom prst="rect">
@@ -4631,19 +4750,19 @@
           <a:p>
             <a:pPr algn="ctr"/>
             <a:r>
-              <a:rPr lang="de-DE" sz="800" dirty="0"/>
-              <a:t>Buzzer</a:t>
-            </a:r>
-            <a:endParaRPr lang="de-DE" dirty="0"/>
-          </a:p>
-        </p:txBody>
-      </p:sp>
-      <p:sp>
-        <p:nvSpPr>
-          <p:cNvPr id="34" name="Rechteck 33">
-            <a:extLst>
-              <a:ext uri="{FF2B5EF4-FFF2-40B4-BE49-F238E27FC236}">
-                <a16:creationId xmlns:a16="http://schemas.microsoft.com/office/drawing/2014/main" id="{0E926472-E580-FE4E-477A-BB32F0C6E98C}"/>
+              <a:rPr lang="de-DE" sz="700" dirty="0"/>
+              <a:t>MUX S0</a:t>
+            </a:r>
+            <a:endParaRPr lang="de-DE" sz="1600" dirty="0"/>
+          </a:p>
+        </p:txBody>
+      </p:sp>
+      <p:sp>
+        <p:nvSpPr>
+          <p:cNvPr id="2" name="Rechteck 1">
+            <a:extLst>
+              <a:ext uri="{FF2B5EF4-FFF2-40B4-BE49-F238E27FC236}">
+                <a16:creationId xmlns:a16="http://schemas.microsoft.com/office/drawing/2014/main" id="{01CE11D2-EBF5-D174-CC35-6DC84C03B68F}"/>
               </a:ext>
             </a:extLst>
           </p:cNvPr>
@@ -4652,7 +4771,7 @@
         </p:nvSpPr>
         <p:spPr>
           <a:xfrm>
-            <a:off x="4626864" y="1963474"/>
+            <a:off x="4626864" y="5719507"/>
             <a:ext cx="792000" cy="155448"/>
           </a:xfrm>
           <a:prstGeom prst="rect">
@@ -4685,10 +4804,10 @@
           <a:p>
             <a:pPr algn="ctr"/>
             <a:r>
-              <a:rPr lang="de-DE" sz="700" dirty="0"/>
-              <a:t>Magnetschalter</a:t>
-            </a:r>
-            <a:endParaRPr lang="de-DE" sz="1600" dirty="0"/>
+              <a:rPr lang="de-DE" sz="800" dirty="0"/>
+              <a:t>Display Hell</a:t>
+            </a:r>
+            <a:endParaRPr lang="de-DE" dirty="0"/>
           </a:p>
         </p:txBody>
       </p:sp>
@@ -5118,7 +5237,7 @@
             <a:pPr algn="ctr"/>
             <a:r>
               <a:rPr lang="de-DE" sz="800" dirty="0"/>
-              <a:t>US Echo L</a:t>
+              <a:t>US Echo R</a:t>
             </a:r>
           </a:p>
         </p:txBody>
@@ -5171,7 +5290,7 @@
             <a:pPr algn="ctr"/>
             <a:r>
               <a:rPr lang="de-DE" sz="800" dirty="0"/>
-              <a:t>US Echo R</a:t>
+              <a:t>US Echo L</a:t>
             </a:r>
           </a:p>
         </p:txBody>
@@ -5277,7 +5396,7 @@
             <a:pPr algn="ctr"/>
             <a:r>
               <a:rPr lang="de-DE" sz="800" dirty="0"/>
-              <a:t>GP2</a:t>
+              <a:t>GP1</a:t>
             </a:r>
           </a:p>
         </p:txBody>
@@ -5330,7 +5449,7 @@
             <a:pPr algn="ctr"/>
             <a:r>
               <a:rPr lang="de-DE" sz="800" dirty="0"/>
-              <a:t>GP3</a:t>
+              <a:t>GP2</a:t>
             </a:r>
           </a:p>
         </p:txBody>
@@ -5383,7 +5502,7 @@
             <a:pPr algn="ctr"/>
             <a:r>
               <a:rPr lang="de-DE" sz="800" dirty="0"/>
-              <a:t>GP4</a:t>
+              <a:t>GP3</a:t>
             </a:r>
           </a:p>
         </p:txBody>
@@ -5436,7 +5555,7 @@
             <a:pPr algn="ctr"/>
             <a:r>
               <a:rPr lang="de-DE" sz="800" dirty="0"/>
-              <a:t>GP5</a:t>
+              <a:t>GP4</a:t>
             </a:r>
           </a:p>
         </p:txBody>
@@ -5489,7 +5608,7 @@
             <a:pPr algn="ctr"/>
             <a:r>
               <a:rPr lang="de-DE" sz="800" dirty="0"/>
-              <a:t>GP28</a:t>
+              <a:t>GP5</a:t>
             </a:r>
           </a:p>
         </p:txBody>

</xml_diff>

<commit_message>
Anpassung Pinout an finale Belegung
</commit_message>
<xml_diff>
--- a/Smarte Mülltonne/Software/Visualisierungen/Pinout Diagramm.pptx
+++ b/Smarte Mülltonne/Software/Visualisierungen/Pinout Diagramm.pptx
@@ -113,25 +113,17 @@
 </p:presentation>
 </file>
 
-<file path=ppt/revisionInfo.xml><?xml version="1.0" encoding="utf-8"?>
-<p1510:revInfo xmlns:a="http://schemas.openxmlformats.org/drawingml/2006/main" xmlns:r="http://schemas.openxmlformats.org/officeDocument/2006/relationships" xmlns:p1510="http://schemas.microsoft.com/office/powerpoint/2015/10/main">
-  <p1510:revLst>
-    <p1510:client id="{13BD13CA-E258-482D-B7BC-0539ADF64448}" v="1" dt="2026-07-04T09:17:30.921"/>
-  </p1510:revLst>
-</p1510:revInfo>
-</file>
-
 <file path=ppt/changesInfos/changesInfo1.xml><?xml version="1.0" encoding="utf-8"?>
 <pc:chgInfo xmlns:a="http://schemas.openxmlformats.org/drawingml/2006/main" xmlns:r="http://schemas.openxmlformats.org/officeDocument/2006/relationships" xmlns:ac="http://schemas.microsoft.com/office/drawing/2013/main/command" xmlns:pc="http://schemas.microsoft.com/office/powerpoint/2013/main/command">
   <pc:docChgLst>
     <pc:chgData name="Theresa Pelz" userId="ddc31a4f-cfff-4679-a101-1188f26643c0" providerId="ADAL" clId="{EB9D3BDE-398B-4CFF-AA99-85D1121C3E11}"/>
-    <pc:docChg chg="custSel modSld">
-      <pc:chgData name="Theresa Pelz" userId="ddc31a4f-cfff-4679-a101-1188f26643c0" providerId="ADAL" clId="{EB9D3BDE-398B-4CFF-AA99-85D1121C3E11}" dt="2026-07-04T09:52:08.366" v="72" actId="20577"/>
+    <pc:docChg chg="undo custSel modSld">
+      <pc:chgData name="Theresa Pelz" userId="ddc31a4f-cfff-4679-a101-1188f26643c0" providerId="ADAL" clId="{EB9D3BDE-398B-4CFF-AA99-85D1121C3E11}" dt="2026-07-05T10:32:59.807" v="96" actId="255"/>
       <pc:docMkLst>
         <pc:docMk/>
       </pc:docMkLst>
       <pc:sldChg chg="addSp delSp modSp mod">
-        <pc:chgData name="Theresa Pelz" userId="ddc31a4f-cfff-4679-a101-1188f26643c0" providerId="ADAL" clId="{EB9D3BDE-398B-4CFF-AA99-85D1121C3E11}" dt="2026-07-04T09:22:36.954" v="57" actId="20577"/>
+        <pc:chgData name="Theresa Pelz" userId="ddc31a4f-cfff-4679-a101-1188f26643c0" providerId="ADAL" clId="{EB9D3BDE-398B-4CFF-AA99-85D1121C3E11}" dt="2026-07-05T10:32:59.807" v="96" actId="255"/>
         <pc:sldMkLst>
           <pc:docMk/>
           <pc:sldMk cId="713369168" sldId="257"/>
@@ -190,6 +182,30 @@
             <pc:docMk/>
             <pc:sldMk cId="713369168" sldId="257"/>
             <ac:spMk id="21" creationId="{D5593BF1-D4AF-67FE-BDED-0677FF5EAD83}"/>
+          </ac:spMkLst>
+        </pc:spChg>
+        <pc:spChg chg="mod">
+          <ac:chgData name="Theresa Pelz" userId="ddc31a4f-cfff-4679-a101-1188f26643c0" providerId="ADAL" clId="{EB9D3BDE-398B-4CFF-AA99-85D1121C3E11}" dt="2026-07-05T10:32:36.375" v="90" actId="404"/>
+          <ac:spMkLst>
+            <pc:docMk/>
+            <pc:sldMk cId="713369168" sldId="257"/>
+            <ac:spMk id="24" creationId="{2C3EB243-86D5-FD8E-7A05-11DA6614DF64}"/>
+          </ac:spMkLst>
+        </pc:spChg>
+        <pc:spChg chg="mod">
+          <ac:chgData name="Theresa Pelz" userId="ddc31a4f-cfff-4679-a101-1188f26643c0" providerId="ADAL" clId="{EB9D3BDE-398B-4CFF-AA99-85D1121C3E11}" dt="2026-07-05T10:32:20.275" v="85" actId="255"/>
+          <ac:spMkLst>
+            <pc:docMk/>
+            <pc:sldMk cId="713369168" sldId="257"/>
+            <ac:spMk id="25" creationId="{E1929955-BC87-EAE5-C210-4322B4B89540}"/>
+          </ac:spMkLst>
+        </pc:spChg>
+        <pc:spChg chg="mod">
+          <ac:chgData name="Theresa Pelz" userId="ddc31a4f-cfff-4679-a101-1188f26643c0" providerId="ADAL" clId="{EB9D3BDE-398B-4CFF-AA99-85D1121C3E11}" dt="2026-07-05T10:32:59.807" v="96" actId="255"/>
+          <ac:spMkLst>
+            <pc:docMk/>
+            <pc:sldMk cId="713369168" sldId="257"/>
+            <ac:spMk id="30" creationId="{EC7594DE-1E11-A10A-ADA7-03E3DD812CE3}"/>
           </ac:spMkLst>
         </pc:spChg>
         <pc:spChg chg="add mod">
@@ -416,7 +432,7 @@
           <a:p>
             <a:fld id="{60A50C7E-A74C-4D92-A00C-070A3D78B4C7}" type="datetimeFigureOut">
               <a:rPr lang="de-DE" smtClean="0"/>
-              <a:t>04.07.2026</a:t>
+              <a:t>05.07.2026</a:t>
             </a:fld>
             <a:endParaRPr lang="de-DE"/>
           </a:p>
@@ -614,7 +630,7 @@
           <a:p>
             <a:fld id="{60A50C7E-A74C-4D92-A00C-070A3D78B4C7}" type="datetimeFigureOut">
               <a:rPr lang="de-DE" smtClean="0"/>
-              <a:t>04.07.2026</a:t>
+              <a:t>05.07.2026</a:t>
             </a:fld>
             <a:endParaRPr lang="de-DE"/>
           </a:p>
@@ -822,7 +838,7 @@
           <a:p>
             <a:fld id="{60A50C7E-A74C-4D92-A00C-070A3D78B4C7}" type="datetimeFigureOut">
               <a:rPr lang="de-DE" smtClean="0"/>
-              <a:t>04.07.2026</a:t>
+              <a:t>05.07.2026</a:t>
             </a:fld>
             <a:endParaRPr lang="de-DE"/>
           </a:p>
@@ -1020,7 +1036,7 @@
           <a:p>
             <a:fld id="{60A50C7E-A74C-4D92-A00C-070A3D78B4C7}" type="datetimeFigureOut">
               <a:rPr lang="de-DE" smtClean="0"/>
-              <a:t>04.07.2026</a:t>
+              <a:t>05.07.2026</a:t>
             </a:fld>
             <a:endParaRPr lang="de-DE"/>
           </a:p>
@@ -1295,7 +1311,7 @@
           <a:p>
             <a:fld id="{60A50C7E-A74C-4D92-A00C-070A3D78B4C7}" type="datetimeFigureOut">
               <a:rPr lang="de-DE" smtClean="0"/>
-              <a:t>04.07.2026</a:t>
+              <a:t>05.07.2026</a:t>
             </a:fld>
             <a:endParaRPr lang="de-DE"/>
           </a:p>
@@ -1560,7 +1576,7 @@
           <a:p>
             <a:fld id="{60A50C7E-A74C-4D92-A00C-070A3D78B4C7}" type="datetimeFigureOut">
               <a:rPr lang="de-DE" smtClean="0"/>
-              <a:t>04.07.2026</a:t>
+              <a:t>05.07.2026</a:t>
             </a:fld>
             <a:endParaRPr lang="de-DE"/>
           </a:p>
@@ -1972,7 +1988,7 @@
           <a:p>
             <a:fld id="{60A50C7E-A74C-4D92-A00C-070A3D78B4C7}" type="datetimeFigureOut">
               <a:rPr lang="de-DE" smtClean="0"/>
-              <a:t>04.07.2026</a:t>
+              <a:t>05.07.2026</a:t>
             </a:fld>
             <a:endParaRPr lang="de-DE"/>
           </a:p>
@@ -2113,7 +2129,7 @@
           <a:p>
             <a:fld id="{60A50C7E-A74C-4D92-A00C-070A3D78B4C7}" type="datetimeFigureOut">
               <a:rPr lang="de-DE" smtClean="0"/>
-              <a:t>04.07.2026</a:t>
+              <a:t>05.07.2026</a:t>
             </a:fld>
             <a:endParaRPr lang="de-DE"/>
           </a:p>
@@ -2226,7 +2242,7 @@
           <a:p>
             <a:fld id="{60A50C7E-A74C-4D92-A00C-070A3D78B4C7}" type="datetimeFigureOut">
               <a:rPr lang="de-DE" smtClean="0"/>
-              <a:t>04.07.2026</a:t>
+              <a:t>05.07.2026</a:t>
             </a:fld>
             <a:endParaRPr lang="de-DE"/>
           </a:p>
@@ -2537,7 +2553,7 @@
           <a:p>
             <a:fld id="{60A50C7E-A74C-4D92-A00C-070A3D78B4C7}" type="datetimeFigureOut">
               <a:rPr lang="de-DE" smtClean="0"/>
-              <a:t>04.07.2026</a:t>
+              <a:t>05.07.2026</a:t>
             </a:fld>
             <a:endParaRPr lang="de-DE"/>
           </a:p>
@@ -2825,7 +2841,7 @@
           <a:p>
             <a:fld id="{60A50C7E-A74C-4D92-A00C-070A3D78B4C7}" type="datetimeFigureOut">
               <a:rPr lang="de-DE" smtClean="0"/>
-              <a:t>04.07.2026</a:t>
+              <a:t>05.07.2026</a:t>
             </a:fld>
             <a:endParaRPr lang="de-DE"/>
           </a:p>
@@ -3066,7 +3082,7 @@
           <a:p>
             <a:fld id="{60A50C7E-A74C-4D92-A00C-070A3D78B4C7}" type="datetimeFigureOut">
               <a:rPr lang="de-DE" smtClean="0"/>
-              <a:t>04.07.2026</a:t>
+              <a:t>05.07.2026</a:t>
             </a:fld>
             <a:endParaRPr lang="de-DE"/>
           </a:p>
@@ -4264,10 +4280,10 @@
           <a:p>
             <a:pPr algn="ctr"/>
             <a:r>
-              <a:rPr lang="de-DE" sz="800" dirty="0"/>
-              <a:t>Touch SCK</a:t>
-            </a:r>
-            <a:endParaRPr lang="de-DE" dirty="0"/>
+              <a:rPr lang="de-DE" sz="700" dirty="0"/>
+              <a:t>Touch SCK/CLK</a:t>
+            </a:r>
+            <a:endParaRPr lang="de-DE" sz="1600" dirty="0"/>
           </a:p>
         </p:txBody>
       </p:sp>
@@ -4318,10 +4334,9 @@
           <a:p>
             <a:pPr algn="ctr"/>
             <a:r>
-              <a:rPr lang="de-DE" sz="800" dirty="0"/>
-              <a:t>Touch MOSI</a:t>
-            </a:r>
-            <a:endParaRPr lang="de-DE" dirty="0"/>
+              <a:rPr lang="de-DE" sz="650" dirty="0"/>
+              <a:t>Touch MOSI/DIN</a:t>
+            </a:r>
           </a:p>
         </p:txBody>
       </p:sp>
@@ -4588,10 +4603,9 @@
           <a:p>
             <a:pPr algn="ctr"/>
             <a:r>
-              <a:rPr lang="de-DE" sz="800" dirty="0"/>
-              <a:t>Touch MISO</a:t>
-            </a:r>
-            <a:endParaRPr lang="de-DE" dirty="0"/>
+              <a:rPr lang="de-DE" sz="650" dirty="0"/>
+              <a:t>Touch MISO/DO</a:t>
+            </a:r>
           </a:p>
         </p:txBody>
       </p:sp>

</xml_diff>